<commit_message>
docs: update IR deck v2 + add competitive landscape and technical architecture briefs
Co-Authored-By: Claude Opus 4.6 <noreply@anthropic.com>
</commit_message>
<xml_diff>
--- a/docs/working_docs/investors/IR Deck - yarnnn - March 2026 v2.pptx
+++ b/docs/working_docs/investors/IR Deck - yarnnn - March 2026 v2.pptx
@@ -27,6 +27,7 @@
     <p:sldId id="278" r:id="rId18"/>
     <p:sldId id="279" r:id="rId19"/>
     <p:sldId id="280" r:id="rId25"/>
+    <p:sldId id="281" r:id="rId26"/>
   </p:sldIdLst>
   <p:sldSz cx="9144000" cy="5143500" type="screen16x9"/>
   <p:notesSz cx="5143500" cy="9144000"/>
@@ -13265,6 +13266,570 @@
 </p:sld>
 </file>
 
+<file path=ppt/slides/slide20.xml><?xml version="1.0" encoding="utf-8"?>
+<p:sld xmlns:a="http://schemas.openxmlformats.org/drawingml/2006/main" xmlns:r="http://schemas.openxmlformats.org/officeDocument/2006/relationships" xmlns:p="http://schemas.openxmlformats.org/presentationml/2006/main">
+  <p:cSld>
+    <p:bg>
+      <p:bgPr>
+        <a:solidFill>
+          <a:srgbClr val="FFFFFF"/>
+        </a:solidFill>
+        <a:effectLst/>
+      </p:bgPr>
+    </p:bg>
+    <p:spTree>
+      <p:nvGrpSpPr>
+        <p:cNvPr id="1" name=""/>
+        <p:cNvGrpSpPr/>
+        <p:nvPr/>
+      </p:nvGrpSpPr>
+      <p:grpSpPr>
+        <a:xfrm>
+          <a:off x="0" y="0"/>
+          <a:ext cx="0" cy="0"/>
+          <a:chOff x="0" y="0"/>
+          <a:chExt cx="0" cy="0"/>
+        </a:xfrm>
+      </p:grpSpPr>
+      <p:sp>
+        <p:nvSpPr>
+          <p:cNvPr id="2" name="SectionLabel"/>
+          <p:cNvSpPr/>
+          <p:nvPr/>
+        </p:nvSpPr>
+        <p:spPr>
+          <a:xfrm>
+            <a:off x="685800" y="365760"/>
+            <a:ext cx="3657600" cy="228600"/>
+          </a:xfrm>
+          <a:prstGeom prst="rect">
+            <a:avLst/>
+          </a:prstGeom>
+          <a:noFill/>
+          <a:ln/>
+        </p:spPr>
+        <p:txBody>
+          <a:bodyPr wrap="square" lIns="0" tIns="0" rIns="0" bIns="0" rtlCol="0" anchor="ctr"/>
+          <a:lstStyle/>
+          <a:p>
+            <a:pPr marL="0" indent="0">
+              <a:buNone/>
+            </a:pPr>
+            <a:r>
+              <a:rPr lang="en-US" sz="1100" b="1" dirty="0">
+                <a:solidFill>
+                  <a:srgbClr val="E8985E"/>
+                </a:solidFill>
+                <a:latin typeface="Arial" pitchFamily="34" charset="0"/>
+              </a:rPr>
+              <a:t>Appendix: Architecture Depth</a:t>
+            </a:r>
+          </a:p>
+        </p:txBody>
+      </p:sp>
+      <p:sp>
+        <p:nvSpPr>
+          <p:cNvPr id="3" name="Title"/>
+          <p:cNvSpPr/>
+          <p:nvPr/>
+        </p:nvSpPr>
+        <p:spPr>
+          <a:xfrm>
+            <a:off x="685800" y="594360"/>
+            <a:ext cx="7772400" cy="457200"/>
+          </a:xfrm>
+          <a:prstGeom prst="rect">
+            <a:avLst/>
+          </a:prstGeom>
+          <a:noFill/>
+          <a:ln/>
+        </p:spPr>
+        <p:txBody>
+          <a:bodyPr wrap="square" lIns="0" tIns="0" rIns="0" bIns="0" rtlCol="0" anchor="ctr"/>
+          <a:lstStyle/>
+          <a:p>
+            <a:pPr marL="0" indent="0">
+              <a:buNone/>
+            </a:pPr>
+            <a:r>
+              <a:rPr lang="en-US" sz="2400" b="1" dirty="0">
+                <a:solidFill>
+                  <a:srgbClr val="111111"/>
+                </a:solidFill>
+                <a:latin typeface="Arial" pitchFamily="34" charset="0"/>
+              </a:rPr>
+              <a:t>What a Well-Funded Team Can’t Shortcut</a:t>
+            </a:r>
+          </a:p>
+        </p:txBody>
+      </p:sp>
+      <p:sp>
+        <p:nvSpPr>
+          <p:cNvPr id="4" name="Subtitle"/>
+          <p:cNvSpPr/>
+          <p:nvPr/>
+        </p:nvSpPr>
+        <p:spPr>
+          <a:xfrm>
+            <a:off x="685800" y="1051560"/>
+            <a:ext cx="7772400" cy="228600"/>
+          </a:xfrm>
+          <a:prstGeom prst="rect">
+            <a:avLst/>
+          </a:prstGeom>
+          <a:noFill/>
+          <a:ln/>
+        </p:spPr>
+        <p:txBody>
+          <a:bodyPr wrap="square" lIns="0" tIns="0" rIns="0" bIns="0" rtlCol="0" anchor="ctr"/>
+          <a:lstStyle/>
+          <a:p>
+            <a:pPr marL="0" indent="0">
+              <a:buNone/>
+            </a:pPr>
+            <a:r>
+              <a:rPr lang="en-US" sz="1100" dirty="0">
+                <a:solidFill>
+                  <a:srgbClr val="999999"/>
+                </a:solidFill>
+                <a:latin typeface="Arial" pitchFamily="34" charset="0"/>
+              </a:rPr>
+              <a:t>Each layer assumes the ones below it exist. 122 Architecture Decision Records document each tradeoff.</a:t>
+            </a:r>
+          </a:p>
+        </p:txBody>
+      </p:sp>
+      <p:sp>
+        <p:nvSpPr>
+          <p:cNvPr id="10" name="Label1"/>
+          <p:cNvSpPr/>
+          <p:nvPr/>
+        </p:nvSpPr>
+        <p:spPr>
+          <a:xfrm>
+            <a:off x="685800" y="1463040"/>
+            <a:ext cx="3840480" cy="228600"/>
+          </a:xfrm>
+          <a:prstGeom prst="rect">
+            <a:avLst/>
+          </a:prstGeom>
+          <a:noFill/>
+          <a:ln/>
+        </p:spPr>
+        <p:txBody>
+          <a:bodyPr wrap="square" lIns="0" tIns="0" rIns="0" bIns="0" rtlCol="0" anchor="ctr"/>
+          <a:lstStyle/>
+          <a:p>
+            <a:pPr marL="0" indent="0">
+              <a:buNone/>
+            </a:pPr>
+            <a:r>
+              <a:rPr lang="en-US" sz="1100" b="1" dirty="0">
+                <a:solidFill>
+                  <a:srgbClr val="E8985E"/>
+                </a:solidFill>
+                <a:latin typeface="Arial" pitchFamily="34" charset="0"/>
+              </a:rPr>
+              <a:t>“Claude Code Online” — Output Gateway</a:t>
+            </a:r>
+          </a:p>
+        </p:txBody>
+      </p:sp>
+      <p:sp>
+        <p:nvSpPr>
+          <p:cNvPr id="11" name="Desc1"/>
+          <p:cNvSpPr/>
+          <p:nvPr/>
+        </p:nvSpPr>
+        <p:spPr>
+          <a:xfrm>
+            <a:off x="685800" y="1691640"/>
+            <a:ext cx="3840480" cy="457200"/>
+          </a:xfrm>
+          <a:prstGeom prst="rect">
+            <a:avLst/>
+          </a:prstGeom>
+          <a:noFill/>
+          <a:ln/>
+        </p:spPr>
+        <p:txBody>
+          <a:bodyPr wrap="square" lIns="0" tIns="0" rIns="0" bIns="0" rtlCol="0" anchor="t"/>
+          <a:lstStyle/>
+          <a:p>
+            <a:pPr marL="0" indent="0">
+              <a:buNone/>
+            </a:pPr>
+            <a:r>
+              <a:rPr lang="en-US" sz="900" dirty="0">
+                <a:solidFill>
+                  <a:srgbClr val="666666"/>
+                </a:solidFill>
+                <a:latin typeface="Arial" pitchFamily="34" charset="0"/>
+              </a:rPr>
+              <a:t>Same capabilities model as Claude Code (SKILL.md + local tools + filesystem), but persistent, autonomous, and cloud-native. Two-filesystem architecture: capability filesystem (skills on Docker) + content filesystem (workspace per agent). Adding a new output format = adding a skill folder.</a:t>
+            </a:r>
+          </a:p>
+        </p:txBody>
+      </p:sp>
+      <p:sp>
+        <p:nvSpPr>
+          <p:cNvPr id="12" name="Label2"/>
+          <p:cNvSpPr/>
+          <p:nvPr/>
+        </p:nvSpPr>
+        <p:spPr>
+          <a:xfrm>
+            <a:off x="4617720" y="1463040"/>
+            <a:ext cx="3840480" cy="228600"/>
+          </a:xfrm>
+          <a:prstGeom prst="rect">
+            <a:avLst/>
+          </a:prstGeom>
+          <a:noFill/>
+          <a:ln/>
+        </p:spPr>
+        <p:txBody>
+          <a:bodyPr wrap="square" lIns="0" tIns="0" rIns="0" bIns="0" rtlCol="0" anchor="ctr"/>
+          <a:lstStyle/>
+          <a:p>
+            <a:pPr marL="0" indent="0">
+              <a:buNone/>
+            </a:pPr>
+            <a:r>
+              <a:rPr lang="en-US" sz="1100" b="1" dirty="0">
+                <a:solidFill>
+                  <a:srgbClr val="E8985E"/>
+                </a:solidFill>
+                <a:latin typeface="Arial" pitchFamily="34" charset="0"/>
+              </a:rPr>
+              <a:t>Autonomous Orchestration — Composer Heartbeat</a:t>
+            </a:r>
+          </a:p>
+        </p:txBody>
+      </p:sp>
+      <p:sp>
+        <p:nvSpPr>
+          <p:cNvPr id="13" name="Desc2"/>
+          <p:cNvSpPr/>
+          <p:nvPr/>
+        </p:nvSpPr>
+        <p:spPr>
+          <a:xfrm>
+            <a:off x="4617720" y="1691640"/>
+            <a:ext cx="3840480" cy="457200"/>
+          </a:xfrm>
+          <a:prstGeom prst="rect">
+            <a:avLst/>
+          </a:prstGeom>
+          <a:noFill/>
+          <a:ln/>
+        </p:spPr>
+        <p:txBody>
+          <a:bodyPr wrap="square" lIns="0" tIns="0" rIns="0" bIns="0" rtlCol="0" anchor="t"/>
+          <a:lstStyle/>
+          <a:p>
+            <a:pPr marL="0" indent="0">
+              <a:buNone/>
+            </a:pPr>
+            <a:r>
+              <a:rPr lang="en-US" sz="900" dirty="0">
+                <a:solidFill>
+                  <a:srgbClr val="666666"/>
+                </a:solidFill>
+                <a:latin typeface="Arial" pitchFamily="34" charset="0"/>
+              </a:rPr>
+              <a:t>A cron-triggered heartbeat assesses the entire agent workforce: substrate signals, content freshness, agent maturity, cross-agent patterns. Creates agents, pauses underperformers, dissolves unused ones, coaches via supervisor notes. No human in the loop.</a:t>
+            </a:r>
+          </a:p>
+        </p:txBody>
+      </p:sp>
+      <p:sp>
+        <p:nvSpPr>
+          <p:cNvPr id="14" name="Label3"/>
+          <p:cNvSpPr/>
+          <p:nvPr/>
+        </p:nvSpPr>
+        <p:spPr>
+          <a:xfrm>
+            <a:off x="685800" y="2331720"/>
+            <a:ext cx="3840480" cy="228600"/>
+          </a:xfrm>
+          <a:prstGeom prst="rect">
+            <a:avLst/>
+          </a:prstGeom>
+          <a:noFill/>
+          <a:ln/>
+        </p:spPr>
+        <p:txBody>
+          <a:bodyPr wrap="square" lIns="0" tIns="0" rIns="0" bIns="0" rtlCol="0" anchor="ctr"/>
+          <a:lstStyle/>
+          <a:p>
+            <a:pPr marL="0" indent="0">
+              <a:buNone/>
+            </a:pPr>
+            <a:r>
+              <a:rPr lang="en-US" sz="1100" b="1" dirty="0">
+                <a:solidFill>
+                  <a:srgbClr val="E8985E"/>
+                </a:solidFill>
+                <a:latin typeface="Arial" pitchFamily="34" charset="0"/>
+              </a:rPr>
+              <a:t>Feedback-to-Intelligence Loop</a:t>
+            </a:r>
+          </a:p>
+        </p:txBody>
+      </p:sp>
+      <p:sp>
+        <p:nvSpPr>
+          <p:cNvPr id="15" name="Desc3"/>
+          <p:cNvSpPr/>
+          <p:nvPr/>
+        </p:nvSpPr>
+        <p:spPr>
+          <a:xfrm>
+            <a:off x="685800" y="2560320"/>
+            <a:ext cx="3840480" cy="457200"/>
+          </a:xfrm>
+          <a:prstGeom prst="rect">
+            <a:avLst/>
+          </a:prstGeom>
+          <a:noFill/>
+          <a:ln/>
+        </p:spPr>
+        <p:txBody>
+          <a:bodyPr wrap="square" lIns="0" tIns="0" rIns="0" bIns="0" rtlCol="0" anchor="t"/>
+          <a:lstStyle/>
+          <a:p>
+            <a:pPr marL="0" indent="0">
+              <a:buNone/>
+            </a:pPr>
+            <a:r>
+              <a:rPr lang="en-US" sz="900" dirty="0">
+                <a:solidFill>
+                  <a:srgbClr val="666666"/>
+                </a:solidFill>
+                <a:latin typeface="Arial" pitchFamily="34" charset="0"/>
+              </a:rPr>
+              <a:t>Three unified feedback rails: user edits distilled to persistent preferences, agent self-reflection after every run, Composer lifecycle coaching. Agents progress through seniority levels (new → associate → senior) with expanding duty portfolios. “Improves with tenure” is structural, not aspirational.</a:t>
+            </a:r>
+          </a:p>
+        </p:txBody>
+      </p:sp>
+      <p:sp>
+        <p:nvSpPr>
+          <p:cNvPr id="16" name="Label4"/>
+          <p:cNvSpPr/>
+          <p:nvPr/>
+        </p:nvSpPr>
+        <p:spPr>
+          <a:xfrm>
+            <a:off x="4617720" y="2331720"/>
+            <a:ext cx="3840480" cy="228600"/>
+          </a:xfrm>
+          <a:prstGeom prst="rect">
+            <a:avLst/>
+          </a:prstGeom>
+          <a:noFill/>
+          <a:ln/>
+        </p:spPr>
+        <p:txBody>
+          <a:bodyPr wrap="square" lIns="0" tIns="0" rIns="0" bIns="0" rtlCol="0" anchor="ctr"/>
+          <a:lstStyle/>
+          <a:p>
+            <a:pPr marL="0" indent="0">
+              <a:buNone/>
+            </a:pPr>
+            <a:r>
+              <a:rPr lang="en-US" sz="1100" b="1" dirty="0">
+                <a:solidFill>
+                  <a:srgbClr val="E8985E"/>
+                </a:solidFill>
+                <a:latin typeface="Arial" pitchFamily="34" charset="0"/>
+              </a:rPr>
+              <a:t>Multi-Agent Project Coordination</a:t>
+            </a:r>
+          </a:p>
+        </p:txBody>
+      </p:sp>
+      <p:sp>
+        <p:nvSpPr>
+          <p:cNvPr id="17" name="Desc4"/>
+          <p:cNvSpPr/>
+          <p:nvPr/>
+        </p:nvSpPr>
+        <p:spPr>
+          <a:xfrm>
+            <a:off x="4617720" y="2560320"/>
+            <a:ext cx="3840480" cy="457200"/>
+          </a:xfrm>
+          <a:prstGeom prst="rect">
+            <a:avLst/>
+          </a:prstGeom>
+          <a:noFill/>
+          <a:ln/>
+        </p:spPr>
+        <p:txBody>
+          <a:bodyPr wrap="square" lIns="0" tIns="0" rIns="0" bIns="0" rtlCol="0" anchor="t"/>
+          <a:lstStyle/>
+          <a:p>
+            <a:pPr marL="0" indent="0">
+              <a:buNone/>
+            </a:pPr>
+            <a:r>
+              <a:rPr lang="en-US" sz="900" dirty="0">
+                <a:solidFill>
+                  <a:srgbClr val="666666"/>
+                </a:solidFill>
+                <a:latin typeface="Arial" pitchFamily="34" charset="0"/>
+              </a:rPr>
+              <a:t>PM agents coordinate contributor agents toward assembled deliverables. Contribution briefs steer agent focus. Quality assessment gates assembly. Work budget governors bound autonomous compute. Intent decomposition translates user goals into bounded, executable work plans.</a:t>
+            </a:r>
+          </a:p>
+        </p:txBody>
+      </p:sp>
+      <p:sp>
+        <p:nvSpPr>
+          <p:cNvPr id="20" name="Divider"/>
+          <p:cNvSpPr/>
+          <p:nvPr/>
+        </p:nvSpPr>
+        <p:spPr>
+          <a:xfrm>
+            <a:off x="685800" y="3200400"/>
+            <a:ext cx="7772400" cy="18000"/>
+          </a:xfrm>
+          <a:prstGeom prst="rect">
+            <a:avLst/>
+          </a:prstGeom>
+          <a:solidFill>
+            <a:srgbClr val="EEEEEE"/>
+          </a:solidFill>
+          <a:ln/>
+        </p:spPr>
+        <p:txBody>
+          <a:bodyPr/>
+          <a:lstStyle/>
+          <a:p>
+            <a:endParaRPr lang="en-KR"/>
+          </a:p>
+        </p:txBody>
+      </p:sp>
+      <p:sp>
+        <p:nvSpPr>
+          <p:cNvPr id="21" name="WhyItMatters"/>
+          <p:cNvSpPr/>
+          <p:nvPr/>
+        </p:nvSpPr>
+        <p:spPr>
+          <a:xfrm>
+            <a:off x="685800" y="3383280"/>
+            <a:ext cx="7772400" cy="228600"/>
+          </a:xfrm>
+          <a:prstGeom prst="rect">
+            <a:avLst/>
+          </a:prstGeom>
+          <a:noFill/>
+          <a:ln/>
+        </p:spPr>
+        <p:txBody>
+          <a:bodyPr wrap="square" lIns="0" tIns="0" rIns="0" bIns="0" rtlCol="0" anchor="ctr"/>
+          <a:lstStyle/>
+          <a:p>
+            <a:pPr marL="0" indent="0">
+              <a:buNone/>
+            </a:pPr>
+            <a:r>
+              <a:rPr lang="en-US" sz="1100" b="1" dirty="0">
+                <a:solidFill>
+                  <a:srgbClr val="111111"/>
+                </a:solidFill>
+                <a:latin typeface="Arial" pitchFamily="34" charset="0"/>
+              </a:rPr>
+              <a:t>Why this compounds into defensibility:</a:t>
+            </a:r>
+          </a:p>
+        </p:txBody>
+      </p:sp>
+      <p:sp>
+        <p:nvSpPr>
+          <p:cNvPr id="22" name="DefenseText"/>
+          <p:cNvSpPr/>
+          <p:nvPr/>
+        </p:nvSpPr>
+        <p:spPr>
+          <a:xfrm>
+            <a:off x="685800" y="3611880"/>
+            <a:ext cx="7772400" cy="640080"/>
+          </a:xfrm>
+          <a:prstGeom prst="rect">
+            <a:avLst/>
+          </a:prstGeom>
+          <a:noFill/>
+          <a:ln/>
+        </p:spPr>
+        <p:txBody>
+          <a:bodyPr wrap="square" lIns="0" tIns="0" rIns="0" bIns="0" rtlCol="0" anchor="t"/>
+          <a:lstStyle/>
+          <a:p>
+            <a:pPr marL="0" indent="0">
+              <a:buNone/>
+            </a:pPr>
+            <a:r>
+              <a:rPr lang="en-US" sz="900" dirty="0">
+                <a:solidFill>
+                  <a:srgbClr val="666666"/>
+                </a:solidFill>
+                <a:latin typeface="Arial" pitchFamily="34" charset="0"/>
+              </a:rPr>
+              <a:t>The Composer heartbeat can’t work without the feedback substrate. The feedback substrate can’t work without the workspace filesystem. The workspace filesystem can’t work without the perception pipeline populating it. Each architectural layer was designed knowing the layers above it would exist. A team starting today would need to discover these interdependencies through the same 122 decisions — or build a simpler system that can’t compound.</a:t>
+            </a:r>
+          </a:p>
+        </p:txBody>
+      </p:sp>
+      <p:sp>
+        <p:nvSpPr>
+          <p:cNvPr id="23" name="Footer"/>
+          <p:cNvSpPr/>
+          <p:nvPr/>
+        </p:nvSpPr>
+        <p:spPr>
+          <a:xfrm>
+            <a:off x="685800" y="4480560"/>
+            <a:ext cx="7772400" cy="274320"/>
+          </a:xfrm>
+          <a:prstGeom prst="rect">
+            <a:avLst/>
+          </a:prstGeom>
+          <a:noFill/>
+          <a:ln/>
+        </p:spPr>
+        <p:txBody>
+          <a:bodyPr wrap="square" lIns="0" tIns="0" rIns="0" bIns="0" rtlCol="0" anchor="ctr"/>
+          <a:lstStyle/>
+          <a:p>
+            <a:pPr marL="0" indent="0" algn="ctr">
+              <a:buNone/>
+            </a:pPr>
+            <a:r>
+              <a:rPr lang="en-US" sz="900" i="1" dirty="0">
+                <a:solidFill>
+                  <a:srgbClr val="E8985E"/>
+                </a:solidFill>
+                <a:latin typeface="Arial" pitchFamily="34" charset="0"/>
+              </a:rPr>
+              <a:t>Full technical architecture brief available on request.</a:t>
+            </a:r>
+          </a:p>
+        </p:txBody>
+      </p:sp>
+    </p:spTree>
+  </p:cSld>
+  <p:clrMapOvr>
+    <a:masterClrMapping/>
+  </p:clrMapOvr>
+</p:sld>
+</file>
+
 <file path=ppt/slides/slide3.xml><?xml version="1.0" encoding="utf-8"?>
 <p:sld xmlns:a="http://schemas.openxmlformats.org/drawingml/2006/main" xmlns:r="http://schemas.openxmlformats.org/officeDocument/2006/relationships" xmlns:p="http://schemas.openxmlformats.org/presentationml/2006/main">
   <p:cSld>

</xml_diff>